<commit_message>
Correcion de algunos detalles en el power point
</commit_message>
<xml_diff>
--- a/Bootstrap_Presentacion.pptx
+++ b/Bootstrap_Presentacion.pptx
@@ -1311,7 +1311,7 @@
               <a:buNone/>
             </a:pPr>
             <a:r>
-              <a:rPr lang="en-US" sz="1900" dirty="0">
+              <a:rPr lang="en-US" sz="2000" dirty="0">
                 <a:solidFill>
                   <a:srgbClr val="EFE9F7"/>
                 </a:solidFill>
@@ -1321,7 +1321,7 @@
               </a:rPr>
               <a:t>El framework CSS que estandarizó el diseño responsive en la web</a:t>
             </a:r>
-            <a:endParaRPr lang="en-US" sz="1900" dirty="0"/>
+            <a:endParaRPr lang="en-US" sz="2000" dirty="0"/>
           </a:p>
         </p:txBody>
       </p:sp>
@@ -1350,7 +1350,7 @@
               <a:buNone/>
             </a:pPr>
             <a:r>
-              <a:rPr lang="en-US" sz="1300" dirty="0">
+              <a:rPr lang="en-US" sz="1400" dirty="0">
                 <a:solidFill>
                   <a:srgbClr val="EFE9F7"/>
                 </a:solidFill>
@@ -1360,7 +1360,7 @@
               </a:rPr>
               <a:t>ISW-521 · Programación en Ambiente Web I  ·  UTN Sede San Carlos  ·  2026-II</a:t>
             </a:r>
-            <a:endParaRPr lang="en-US" sz="1300" dirty="0"/>
+            <a:endParaRPr lang="en-US" sz="1400" dirty="0"/>
           </a:p>
         </p:txBody>
       </p:sp>
@@ -1389,7 +1389,7 @@
               <a:buNone/>
             </a:pPr>
             <a:r>
-              <a:rPr lang="en-US" sz="1200" i="1" dirty="0" err="1">
+              <a:rPr lang="en-US" sz="1400" i="1" dirty="0" err="1">
                 <a:solidFill>
                   <a:srgbClr val="EFE9F7"/>
                 </a:solidFill>
@@ -1400,7 +1400,7 @@
               <a:t>Integrantes</a:t>
             </a:r>
             <a:r>
-              <a:rPr lang="en-US" sz="1200" i="1" dirty="0">
+              <a:rPr lang="en-US" sz="1400" i="1" dirty="0">
                 <a:solidFill>
                   <a:srgbClr val="EFE9F7"/>
                 </a:solidFill>
@@ -1411,7 +1411,7 @@
               <a:t>: Samuel </a:t>
             </a:r>
             <a:r>
-              <a:rPr lang="es-ES" sz="1200" i="1" dirty="0">
+              <a:rPr lang="es-ES" sz="1400" i="1" dirty="0">
                 <a:solidFill>
                   <a:srgbClr val="EFE9F7"/>
                 </a:solidFill>
@@ -1422,7 +1422,7 @@
               <a:t>Fernández</a:t>
             </a:r>
             <a:r>
-              <a:rPr lang="en-US" sz="1200" i="1" dirty="0">
+              <a:rPr lang="en-US" sz="1400" i="1" dirty="0">
                 <a:solidFill>
                   <a:srgbClr val="EFE9F7"/>
                 </a:solidFill>
@@ -1432,7 +1432,7 @@
               </a:rPr>
               <a:t> · Alejandro Corrales · Ulises</a:t>
             </a:r>
-            <a:endParaRPr lang="en-US" sz="1200" dirty="0"/>
+            <a:endParaRPr lang="en-US" sz="1400" dirty="0"/>
           </a:p>
         </p:txBody>
       </p:sp>
@@ -1516,7 +1516,7 @@
           <a:bodyPr/>
           <a:lstStyle/>
           <a:p>
-            <a:endParaRPr lang="es-ES"/>
+            <a:endParaRPr lang="es-ES" sz="2000"/>
           </a:p>
         </p:txBody>
       </p:sp>
@@ -1569,7 +1569,7 @@
               <a:buNone/>
             </a:pPr>
             <a:r>
-              <a:rPr lang="en-US" sz="2800" b="1" dirty="0">
+              <a:rPr lang="en-US" sz="3200" b="1" dirty="0">
                 <a:solidFill>
                   <a:srgbClr val="1E1B2E"/>
                 </a:solidFill>
@@ -1579,7 +1579,7 @@
               </a:rPr>
               <a:t>¿Qué es y qué problema resuelve?</a:t>
             </a:r>
-            <a:endParaRPr lang="en-US" sz="2800" dirty="0"/>
+            <a:endParaRPr lang="en-US" sz="3200" dirty="0"/>
           </a:p>
         </p:txBody>
       </p:sp>
@@ -1615,7 +1615,7 @@
           <a:bodyPr/>
           <a:lstStyle/>
           <a:p>
-            <a:endParaRPr lang="es-ES"/>
+            <a:endParaRPr lang="es-ES" sz="2000"/>
           </a:p>
         </p:txBody>
       </p:sp>
@@ -1644,7 +1644,7 @@
               <a:buNone/>
             </a:pPr>
             <a:r>
-              <a:rPr lang="en-US" sz="1700" b="1" dirty="0">
+              <a:rPr lang="en-US" b="1" dirty="0">
                 <a:solidFill>
                   <a:srgbClr val="44337A"/>
                 </a:solidFill>
@@ -1654,7 +1654,7 @@
               </a:rPr>
               <a:t>El problema histórico</a:t>
             </a:r>
-            <a:endParaRPr lang="en-US" sz="1700" dirty="0"/>
+            <a:endParaRPr lang="en-US" dirty="0"/>
           </a:p>
         </p:txBody>
       </p:sp>
@@ -1687,7 +1687,7 @@
               <a:buChar char="•"/>
             </a:pPr>
             <a:r>
-              <a:rPr lang="en-US" sz="1350" dirty="0">
+              <a:rPr lang="en-US" sz="1400" dirty="0">
                 <a:solidFill>
                   <a:srgbClr val="1E1B2E"/>
                 </a:solidFill>
@@ -1697,7 +1697,7 @@
               </a:rPr>
               <a:t>Antes de 2011, cada equipo escribía su propio CSS responsive desde cero.</a:t>
             </a:r>
-            <a:endParaRPr lang="en-US" sz="1350" dirty="0"/>
+            <a:endParaRPr lang="en-US" sz="1400" dirty="0"/>
           </a:p>
           <a:p>
             <a:pPr marL="342900" indent="-342900">
@@ -1708,7 +1708,7 @@
               <a:buChar char="•"/>
             </a:pPr>
             <a:r>
-              <a:rPr lang="en-US" sz="1350" dirty="0">
+              <a:rPr lang="en-US" sz="1400" dirty="0">
                 <a:solidFill>
                   <a:srgbClr val="1E1B2E"/>
                 </a:solidFill>
@@ -1718,7 +1718,7 @@
               </a:rPr>
               <a:t>Resultado: inconsistencia visual y mucho tiempo perdido reinventando botones, formularios y grids.</a:t>
             </a:r>
-            <a:endParaRPr lang="en-US" sz="1350" dirty="0"/>
+            <a:endParaRPr lang="en-US" sz="1400" dirty="0"/>
           </a:p>
           <a:p>
             <a:pPr marL="342900" indent="-342900">
@@ -1729,7 +1729,7 @@
               <a:buChar char="•"/>
             </a:pPr>
             <a:r>
-              <a:rPr lang="en-US" sz="1350" dirty="0">
+              <a:rPr lang="en-US" sz="1400" dirty="0">
                 <a:solidFill>
                   <a:srgbClr val="1E1B2E"/>
                 </a:solidFill>
@@ -1739,7 +1739,7 @@
               </a:rPr>
               <a:t>Bootstrap nació dentro de Twitter, creado por Mark Otto y Jacob Thornton, para dar consistencia de interfaz sin depender de un diseñador en cada feature.</a:t>
             </a:r>
-            <a:endParaRPr lang="en-US" sz="1350" dirty="0"/>
+            <a:endParaRPr lang="en-US" sz="1400" dirty="0"/>
           </a:p>
         </p:txBody>
       </p:sp>
@@ -1775,7 +1775,7 @@
           <a:bodyPr/>
           <a:lstStyle/>
           <a:p>
-            <a:endParaRPr lang="es-ES"/>
+            <a:endParaRPr lang="es-ES" sz="2000"/>
           </a:p>
         </p:txBody>
       </p:sp>
@@ -1804,7 +1804,7 @@
               <a:buNone/>
             </a:pPr>
             <a:r>
-              <a:rPr lang="en-US" sz="1700" b="1" dirty="0">
+              <a:rPr lang="en-US" b="1" dirty="0">
                 <a:solidFill>
                   <a:srgbClr val="FFFFFF"/>
                 </a:solidFill>
@@ -1814,7 +1814,7 @@
               </a:rPr>
               <a:t>Definición técnica</a:t>
             </a:r>
-            <a:endParaRPr lang="en-US" sz="1700" dirty="0"/>
+            <a:endParaRPr lang="en-US" dirty="0"/>
           </a:p>
         </p:txBody>
       </p:sp>
@@ -1846,7 +1846,7 @@
               <a:buNone/>
             </a:pPr>
             <a:r>
-              <a:rPr lang="en-US" sz="1350" dirty="0">
+              <a:rPr lang="en-US" sz="1400" dirty="0">
                 <a:solidFill>
                   <a:srgbClr val="EFE9F7"/>
                 </a:solidFill>
@@ -1856,7 +1856,7 @@
               </a:rPr>
               <a:t>Framework de código abierto compuesto de tres piezas:</a:t>
             </a:r>
-            <a:endParaRPr lang="en-US" sz="1350" dirty="0"/>
+            <a:endParaRPr lang="en-US" sz="1400" dirty="0"/>
           </a:p>
           <a:p>
             <a:pPr marL="342900" indent="-342900">
@@ -1867,7 +1867,7 @@
               <a:buChar char="•"/>
             </a:pPr>
             <a:r>
-              <a:rPr lang="en-US" sz="1350" dirty="0">
+              <a:rPr lang="en-US" sz="1400" dirty="0">
                 <a:solidFill>
                   <a:srgbClr val="EFE9F7"/>
                 </a:solidFill>
@@ -1877,7 +1877,7 @@
               </a:rPr>
               <a:t>Hoja de estilos CSS con clases reutilizables (componentes + utilidades)</a:t>
             </a:r>
-            <a:endParaRPr lang="en-US" sz="1350" dirty="0"/>
+            <a:endParaRPr lang="en-US" sz="1400" dirty="0"/>
           </a:p>
           <a:p>
             <a:pPr marL="342900" indent="-342900">
@@ -1888,7 +1888,7 @@
               <a:buChar char="•"/>
             </a:pPr>
             <a:r>
-              <a:rPr lang="en-US" sz="1350" dirty="0">
+              <a:rPr lang="en-US" sz="1400" dirty="0">
                 <a:solidFill>
                   <a:srgbClr val="EFE9F7"/>
                 </a:solidFill>
@@ -1898,7 +1898,7 @@
               </a:rPr>
               <a:t>Sistema de grid de 12 columnas basado en Flexbox</a:t>
             </a:r>
-            <a:endParaRPr lang="en-US" sz="1350" dirty="0"/>
+            <a:endParaRPr lang="en-US" sz="1400" dirty="0"/>
           </a:p>
           <a:p>
             <a:pPr marL="342900" indent="-342900">
@@ -1909,7 +1909,7 @@
               <a:buChar char="•"/>
             </a:pPr>
             <a:r>
-              <a:rPr lang="en-US" sz="1350" dirty="0">
+              <a:rPr lang="en-US" sz="1400" dirty="0">
                 <a:solidFill>
                   <a:srgbClr val="EFE9F7"/>
                 </a:solidFill>
@@ -1919,7 +1919,7 @@
               </a:rPr>
               <a:t>Bundle de JavaScript para componentes interactivos (modales, dropdowns, carousels)</a:t>
             </a:r>
-            <a:endParaRPr lang="en-US" sz="1350" dirty="0"/>
+            <a:endParaRPr lang="en-US" sz="1400" dirty="0"/>
           </a:p>
         </p:txBody>
       </p:sp>
@@ -2057,7 +2057,7 @@
           <a:bodyPr/>
           <a:lstStyle/>
           <a:p>
-            <a:endParaRPr lang="es-ES"/>
+            <a:endParaRPr lang="es-ES" sz="2000"/>
           </a:p>
         </p:txBody>
       </p:sp>
@@ -2110,7 +2110,7 @@
               <a:buNone/>
             </a:pPr>
             <a:r>
-              <a:rPr lang="en-US" sz="2800" b="1" dirty="0">
+              <a:rPr lang="en-US" sz="3200" b="1" dirty="0">
                 <a:solidFill>
                   <a:srgbClr val="1E1B2E"/>
                 </a:solidFill>
@@ -2120,7 +2120,7 @@
               </a:rPr>
               <a:t>¿Cómo funciona internamente?</a:t>
             </a:r>
-            <a:endParaRPr lang="en-US" sz="2800" dirty="0"/>
+            <a:endParaRPr lang="en-US" sz="3200" dirty="0"/>
           </a:p>
         </p:txBody>
       </p:sp>
@@ -2149,7 +2149,7 @@
               <a:buNone/>
             </a:pPr>
             <a:r>
-              <a:rPr lang="en-US" sz="1350" i="1" dirty="0">
+              <a:rPr lang="en-US" sz="1400" i="1" dirty="0">
                 <a:solidFill>
                   <a:srgbClr val="5A5A6E"/>
                 </a:solidFill>
@@ -2159,7 +2159,7 @@
               </a:rPr>
               <a:t>Arquitectura en 3 capas, de la base a la interfaz</a:t>
             </a:r>
-            <a:endParaRPr lang="en-US" sz="1350" dirty="0"/>
+            <a:endParaRPr lang="en-US" sz="1400" dirty="0"/>
           </a:p>
         </p:txBody>
       </p:sp>
@@ -2200,7 +2200,7 @@
           <a:bodyPr/>
           <a:lstStyle/>
           <a:p>
-            <a:endParaRPr lang="es-ES"/>
+            <a:endParaRPr lang="es-ES" sz="2000"/>
           </a:p>
         </p:txBody>
       </p:sp>
@@ -2227,7 +2227,7 @@
           <a:bodyPr/>
           <a:lstStyle/>
           <a:p>
-            <a:endParaRPr lang="es-ES"/>
+            <a:endParaRPr lang="es-ES" sz="2000"/>
           </a:p>
         </p:txBody>
       </p:sp>
@@ -2256,7 +2256,7 @@
               <a:buNone/>
             </a:pPr>
             <a:r>
-              <a:rPr lang="en-US" sz="1800" b="1" dirty="0">
+              <a:rPr lang="en-US" sz="2000" b="1" dirty="0">
                 <a:solidFill>
                   <a:srgbClr val="FFFFFF"/>
                 </a:solidFill>
@@ -2266,7 +2266,7 @@
               </a:rPr>
               <a:t>1</a:t>
             </a:r>
-            <a:endParaRPr lang="en-US" sz="1800" dirty="0"/>
+            <a:endParaRPr lang="en-US" sz="2000" dirty="0"/>
           </a:p>
         </p:txBody>
       </p:sp>
@@ -2295,7 +2295,7 @@
               <a:buNone/>
             </a:pPr>
             <a:r>
-              <a:rPr lang="en-US" sz="1600" b="1" dirty="0">
+              <a:rPr lang="en-US" b="1" dirty="0">
                 <a:solidFill>
                   <a:srgbClr val="7952B3"/>
                 </a:solidFill>
@@ -2305,7 +2305,7 @@
               </a:rPr>
               <a:t>1. Variables Sass</a:t>
             </a:r>
-            <a:endParaRPr lang="en-US" sz="1600" dirty="0"/>
+            <a:endParaRPr lang="en-US" dirty="0"/>
           </a:p>
         </p:txBody>
       </p:sp>
@@ -2334,7 +2334,7 @@
               <a:buNone/>
             </a:pPr>
             <a:r>
-              <a:rPr lang="en-US" sz="1250" dirty="0">
+              <a:rPr lang="en-US" sz="1400" dirty="0">
                 <a:solidFill>
                   <a:srgbClr val="5A5A6E"/>
                 </a:solidFill>
@@ -2344,7 +2344,7 @@
               </a:rPr>
               <a:t>Colores, espaciados y tipografía se centralizan en _variables.scss. Cambiar una variable y recompilar actualiza todo el tema visual.</a:t>
             </a:r>
-            <a:endParaRPr lang="en-US" sz="1250" dirty="0"/>
+            <a:endParaRPr lang="en-US" sz="1400" dirty="0"/>
           </a:p>
         </p:txBody>
       </p:sp>
@@ -2385,7 +2385,7 @@
           <a:bodyPr/>
           <a:lstStyle/>
           <a:p>
-            <a:endParaRPr lang="es-ES"/>
+            <a:endParaRPr lang="es-ES" sz="2000"/>
           </a:p>
         </p:txBody>
       </p:sp>
@@ -2412,7 +2412,7 @@
           <a:bodyPr/>
           <a:lstStyle/>
           <a:p>
-            <a:endParaRPr lang="es-ES"/>
+            <a:endParaRPr lang="es-ES" sz="2000"/>
           </a:p>
         </p:txBody>
       </p:sp>
@@ -2441,7 +2441,7 @@
               <a:buNone/>
             </a:pPr>
             <a:r>
-              <a:rPr lang="en-US" sz="1800" b="1" dirty="0">
+              <a:rPr lang="en-US" sz="2000" b="1" dirty="0">
                 <a:solidFill>
                   <a:srgbClr val="FFFFFF"/>
                 </a:solidFill>
@@ -2451,7 +2451,7 @@
               </a:rPr>
               <a:t>2</a:t>
             </a:r>
-            <a:endParaRPr lang="en-US" sz="1800" dirty="0"/>
+            <a:endParaRPr lang="en-US" sz="2000" dirty="0"/>
           </a:p>
         </p:txBody>
       </p:sp>
@@ -2480,7 +2480,7 @@
               <a:buNone/>
             </a:pPr>
             <a:r>
-              <a:rPr lang="en-US" sz="1600" b="1" dirty="0">
+              <a:rPr lang="en-US" b="1" dirty="0">
                 <a:solidFill>
                   <a:srgbClr val="44337A"/>
                 </a:solidFill>
@@ -2490,7 +2490,7 @@
               </a:rPr>
               <a:t>2. Sistema de Grid</a:t>
             </a:r>
-            <a:endParaRPr lang="en-US" sz="1600" dirty="0"/>
+            <a:endParaRPr lang="en-US" dirty="0"/>
           </a:p>
         </p:txBody>
       </p:sp>
@@ -2519,7 +2519,7 @@
               <a:buNone/>
             </a:pPr>
             <a:r>
-              <a:rPr lang="en-US" sz="1250" dirty="0">
+              <a:rPr lang="en-US" sz="1400" dirty="0">
                 <a:solidFill>
                   <a:srgbClr val="5A5A6E"/>
                 </a:solidFill>
@@ -2529,7 +2529,7 @@
               </a:rPr>
               <a:t>12 columnas con Flexbox: container &gt; row &gt; col-*. Los breakpoints (sm/md/lg/xl/xxl) son @media queries predefinidos.</a:t>
             </a:r>
-            <a:endParaRPr lang="en-US" sz="1250" dirty="0"/>
+            <a:endParaRPr lang="en-US" sz="1400" dirty="0"/>
           </a:p>
         </p:txBody>
       </p:sp>
@@ -2597,7 +2597,7 @@
           <a:bodyPr/>
           <a:lstStyle/>
           <a:p>
-            <a:endParaRPr lang="es-ES"/>
+            <a:endParaRPr lang="es-ES" sz="2000"/>
           </a:p>
         </p:txBody>
       </p:sp>
@@ -2626,7 +2626,7 @@
               <a:buNone/>
             </a:pPr>
             <a:r>
-              <a:rPr lang="en-US" sz="1800" b="1" dirty="0">
+              <a:rPr lang="en-US" sz="2000" b="1" dirty="0">
                 <a:solidFill>
                   <a:srgbClr val="FFFFFF"/>
                 </a:solidFill>
@@ -2636,7 +2636,7 @@
               </a:rPr>
               <a:t>3</a:t>
             </a:r>
-            <a:endParaRPr lang="en-US" sz="1800" dirty="0"/>
+            <a:endParaRPr lang="en-US" sz="2000" dirty="0"/>
           </a:p>
         </p:txBody>
       </p:sp>
@@ -2665,7 +2665,7 @@
               <a:buNone/>
             </a:pPr>
             <a:r>
-              <a:rPr lang="en-US" sz="1600" b="1" dirty="0">
+              <a:rPr lang="en-US" b="1" dirty="0">
                 <a:solidFill>
                   <a:srgbClr val="1E1B2E"/>
                 </a:solidFill>
@@ -2675,7 +2675,7 @@
               </a:rPr>
               <a:t>3. Componentes + JS</a:t>
             </a:r>
-            <a:endParaRPr lang="en-US" sz="1600" dirty="0"/>
+            <a:endParaRPr lang="en-US" dirty="0"/>
           </a:p>
         </p:txBody>
       </p:sp>
@@ -2704,7 +2704,7 @@
               <a:buNone/>
             </a:pPr>
             <a:r>
-              <a:rPr lang="en-US" sz="1250" dirty="0">
+              <a:rPr lang="en-US" sz="1400" dirty="0">
                 <a:solidFill>
                   <a:srgbClr val="5A5A6E"/>
                 </a:solidFill>
@@ -2714,7 +2714,7 @@
               </a:rPr>
               <a:t>Clases CSS para botones, cards, navbars. El bundle JS (con Popper.js) maneja modales, dropdowns y tooltips.</a:t>
             </a:r>
-            <a:endParaRPr lang="en-US" sz="1250" dirty="0"/>
+            <a:endParaRPr lang="en-US" sz="1400" dirty="0"/>
           </a:p>
         </p:txBody>
       </p:sp>
@@ -2852,7 +2852,7 @@
           <a:bodyPr/>
           <a:lstStyle/>
           <a:p>
-            <a:endParaRPr lang="es-ES"/>
+            <a:endParaRPr lang="es-ES" sz="2000"/>
           </a:p>
         </p:txBody>
       </p:sp>
@@ -2905,7 +2905,7 @@
               <a:buNone/>
             </a:pPr>
             <a:r>
-              <a:rPr lang="en-US" sz="2800" b="1" dirty="0">
+              <a:rPr lang="en-US" sz="3200" b="1" dirty="0">
                 <a:solidFill>
                   <a:srgbClr val="1E1B2E"/>
                 </a:solidFill>
@@ -2915,7 +2915,7 @@
               </a:rPr>
               <a:t>El grid de 12 columnas en acción</a:t>
             </a:r>
-            <a:endParaRPr lang="en-US" sz="2800" dirty="0"/>
+            <a:endParaRPr lang="en-US" sz="3200" dirty="0"/>
           </a:p>
         </p:txBody>
       </p:sp>
@@ -2947,7 +2947,7 @@
           <a:bodyPr/>
           <a:lstStyle/>
           <a:p>
-            <a:endParaRPr lang="es-ES"/>
+            <a:endParaRPr lang="es-ES" sz="2000"/>
           </a:p>
         </p:txBody>
       </p:sp>
@@ -2979,7 +2979,7 @@
           <a:bodyPr/>
           <a:lstStyle/>
           <a:p>
-            <a:endParaRPr lang="es-ES"/>
+            <a:endParaRPr lang="es-ES" sz="2000"/>
           </a:p>
         </p:txBody>
       </p:sp>
@@ -3011,7 +3011,7 @@
           <a:bodyPr/>
           <a:lstStyle/>
           <a:p>
-            <a:endParaRPr lang="es-ES"/>
+            <a:endParaRPr lang="es-ES" sz="2000"/>
           </a:p>
         </p:txBody>
       </p:sp>
@@ -3043,7 +3043,7 @@
           <a:bodyPr/>
           <a:lstStyle/>
           <a:p>
-            <a:endParaRPr lang="es-ES"/>
+            <a:endParaRPr lang="es-ES" sz="2000"/>
           </a:p>
         </p:txBody>
       </p:sp>
@@ -3075,7 +3075,7 @@
           <a:bodyPr/>
           <a:lstStyle/>
           <a:p>
-            <a:endParaRPr lang="es-ES"/>
+            <a:endParaRPr lang="es-ES" sz="2000"/>
           </a:p>
         </p:txBody>
       </p:sp>
@@ -3107,7 +3107,7 @@
           <a:bodyPr/>
           <a:lstStyle/>
           <a:p>
-            <a:endParaRPr lang="es-ES"/>
+            <a:endParaRPr lang="es-ES" sz="2000"/>
           </a:p>
         </p:txBody>
       </p:sp>
@@ -3139,7 +3139,7 @@
           <a:bodyPr/>
           <a:lstStyle/>
           <a:p>
-            <a:endParaRPr lang="es-ES"/>
+            <a:endParaRPr lang="es-ES" sz="2000"/>
           </a:p>
         </p:txBody>
       </p:sp>
@@ -3171,7 +3171,7 @@
           <a:bodyPr/>
           <a:lstStyle/>
           <a:p>
-            <a:endParaRPr lang="es-ES"/>
+            <a:endParaRPr lang="es-ES" sz="2000"/>
           </a:p>
         </p:txBody>
       </p:sp>
@@ -3203,7 +3203,7 @@
           <a:bodyPr/>
           <a:lstStyle/>
           <a:p>
-            <a:endParaRPr lang="es-ES"/>
+            <a:endParaRPr lang="es-ES" sz="2000"/>
           </a:p>
         </p:txBody>
       </p:sp>
@@ -3235,7 +3235,7 @@
           <a:bodyPr/>
           <a:lstStyle/>
           <a:p>
-            <a:endParaRPr lang="es-ES"/>
+            <a:endParaRPr lang="es-ES" sz="2000"/>
           </a:p>
         </p:txBody>
       </p:sp>
@@ -3267,7 +3267,7 @@
           <a:bodyPr/>
           <a:lstStyle/>
           <a:p>
-            <a:endParaRPr lang="es-ES"/>
+            <a:endParaRPr lang="es-ES" sz="2000"/>
           </a:p>
         </p:txBody>
       </p:sp>
@@ -3328,7 +3328,7 @@
               <a:buNone/>
             </a:pPr>
             <a:r>
-              <a:rPr lang="en-US" sz="1150" i="1" dirty="0">
+              <a:rPr lang="en-US" sz="1200" i="1" dirty="0">
                 <a:solidFill>
                   <a:srgbClr val="5A5A6E"/>
                 </a:solidFill>
@@ -3338,7 +3338,7 @@
               </a:rPr>
               <a:t>container &gt; row &gt; 12 columnas disponibles</a:t>
             </a:r>
-            <a:endParaRPr lang="en-US" sz="1150" dirty="0"/>
+            <a:endParaRPr lang="en-US" sz="1200" dirty="0"/>
           </a:p>
         </p:txBody>
       </p:sp>
@@ -3367,19 +3367,155 @@
           <a:bodyPr/>
           <a:lstStyle/>
           <a:p>
+            <a:endParaRPr lang="es-ES" sz="2000"/>
+          </a:p>
+        </p:txBody>
+      </p:sp>
+      <p:sp>
+        <p:nvSpPr>
+          <p:cNvPr id="19" name="Text 16"/>
+          <p:cNvSpPr/>
+          <p:nvPr/>
+        </p:nvSpPr>
+        <p:spPr>
+          <a:xfrm>
+            <a:off x="548640" y="2743200"/>
+            <a:ext cx="3657600" cy="914400"/>
+          </a:xfrm>
+          <a:prstGeom prst="rect">
+            <a:avLst/>
+          </a:prstGeom>
+          <a:noFill/>
+          <a:ln/>
+        </p:spPr>
+        <p:txBody>
+          <a:bodyPr wrap="square" rtlCol="0" anchor="ctr"/>
+          <a:lstStyle/>
+          <a:p>
+            <a:pPr marL="0" indent="0" algn="ctr">
+              <a:buNone/>
+            </a:pPr>
+            <a:r>
+              <a:rPr lang="en-US" sz="1600" b="1" dirty="0">
+                <a:solidFill>
+                  <a:srgbClr val="FFFFFF"/>
+                </a:solidFill>
+                <a:latin typeface="Calibri" pitchFamily="34" charset="0"/>
+                <a:ea typeface="Calibri" pitchFamily="34" charset="-122"/>
+                <a:cs typeface="Calibri" pitchFamily="34" charset="-120"/>
+              </a:rPr>
+              <a:t>col-md-4</a:t>
+            </a:r>
+            <a:endParaRPr lang="en-US" sz="1600" dirty="0"/>
+          </a:p>
+        </p:txBody>
+      </p:sp>
+      <p:sp>
+        <p:nvSpPr>
+          <p:cNvPr id="20" name="Shape 17"/>
+          <p:cNvSpPr/>
+          <p:nvPr/>
+        </p:nvSpPr>
+        <p:spPr>
+          <a:xfrm>
+            <a:off x="4325112" y="2743200"/>
+            <a:ext cx="3657600" cy="914400"/>
+          </a:xfrm>
+          <a:prstGeom prst="roundRect">
+            <a:avLst>
+              <a:gd name="adj" fmla="val 6000"/>
+            </a:avLst>
+          </a:prstGeom>
+          <a:solidFill>
+            <a:srgbClr val="7952B3"/>
+          </a:solidFill>
+          <a:ln/>
+        </p:spPr>
+        <p:txBody>
+          <a:bodyPr/>
+          <a:lstStyle/>
+          <a:p>
+            <a:endParaRPr lang="es-ES" sz="2000"/>
+          </a:p>
+        </p:txBody>
+      </p:sp>
+      <p:sp>
+        <p:nvSpPr>
+          <p:cNvPr id="21" name="Text 18"/>
+          <p:cNvSpPr/>
+          <p:nvPr/>
+        </p:nvSpPr>
+        <p:spPr>
+          <a:xfrm>
+            <a:off x="4325112" y="2743200"/>
+            <a:ext cx="3657600" cy="914400"/>
+          </a:xfrm>
+          <a:prstGeom prst="rect">
+            <a:avLst/>
+          </a:prstGeom>
+          <a:noFill/>
+          <a:ln/>
+        </p:spPr>
+        <p:txBody>
+          <a:bodyPr wrap="square" rtlCol="0" anchor="ctr"/>
+          <a:lstStyle/>
+          <a:p>
+            <a:pPr marL="0" indent="0" algn="ctr">
+              <a:buNone/>
+            </a:pPr>
+            <a:r>
+              <a:rPr lang="en-US" sz="1600" b="1" dirty="0">
+                <a:solidFill>
+                  <a:srgbClr val="FFFFFF"/>
+                </a:solidFill>
+                <a:latin typeface="Calibri" pitchFamily="34" charset="0"/>
+                <a:ea typeface="Calibri" pitchFamily="34" charset="-122"/>
+                <a:cs typeface="Calibri" pitchFamily="34" charset="-120"/>
+              </a:rPr>
+              <a:t>col-md-4</a:t>
+            </a:r>
+            <a:endParaRPr lang="en-US" sz="1600" dirty="0"/>
+          </a:p>
+        </p:txBody>
+      </p:sp>
+      <p:sp>
+        <p:nvSpPr>
+          <p:cNvPr id="22" name="Shape 19"/>
+          <p:cNvSpPr/>
+          <p:nvPr/>
+        </p:nvSpPr>
+        <p:spPr>
+          <a:xfrm>
+            <a:off x="8101584" y="2743200"/>
+            <a:ext cx="3657600" cy="914400"/>
+          </a:xfrm>
+          <a:prstGeom prst="roundRect">
+            <a:avLst>
+              <a:gd name="adj" fmla="val 6000"/>
+            </a:avLst>
+          </a:prstGeom>
+          <a:solidFill>
+            <a:srgbClr val="7952B3"/>
+          </a:solidFill>
+          <a:ln/>
+        </p:spPr>
+        <p:txBody>
+          <a:bodyPr/>
+          <a:lstStyle/>
+          <a:p>
             <a:endParaRPr lang="es-ES"/>
           </a:p>
         </p:txBody>
       </p:sp>
       <p:sp>
         <p:nvSpPr>
-          <p:cNvPr id="19" name="Text 16"/>
-          <p:cNvSpPr/>
-          <p:nvPr/>
-        </p:nvSpPr>
-        <p:spPr>
-          <a:xfrm>
-            <a:off x="548640" y="2743200"/>
+          <p:cNvPr id="23" name="Text 20"/>
+          <p:cNvSpPr/>
+          <p:nvPr/>
+        </p:nvSpPr>
+        <p:spPr>
+          <a:xfrm>
+            <a:off x="8101584" y="2743200"/>
             <a:ext cx="3657600" cy="914400"/>
           </a:xfrm>
           <a:prstGeom prst="rect">
@@ -3412,142 +3548,6 @@
       </p:sp>
       <p:sp>
         <p:nvSpPr>
-          <p:cNvPr id="20" name="Shape 17"/>
-          <p:cNvSpPr/>
-          <p:nvPr/>
-        </p:nvSpPr>
-        <p:spPr>
-          <a:xfrm>
-            <a:off x="4325112" y="2743200"/>
-            <a:ext cx="3657600" cy="914400"/>
-          </a:xfrm>
-          <a:prstGeom prst="roundRect">
-            <a:avLst>
-              <a:gd name="adj" fmla="val 6000"/>
-            </a:avLst>
-          </a:prstGeom>
-          <a:solidFill>
-            <a:srgbClr val="7952B3"/>
-          </a:solidFill>
-          <a:ln/>
-        </p:spPr>
-        <p:txBody>
-          <a:bodyPr/>
-          <a:lstStyle/>
-          <a:p>
-            <a:endParaRPr lang="es-ES"/>
-          </a:p>
-        </p:txBody>
-      </p:sp>
-      <p:sp>
-        <p:nvSpPr>
-          <p:cNvPr id="21" name="Text 18"/>
-          <p:cNvSpPr/>
-          <p:nvPr/>
-        </p:nvSpPr>
-        <p:spPr>
-          <a:xfrm>
-            <a:off x="4325112" y="2743200"/>
-            <a:ext cx="3657600" cy="914400"/>
-          </a:xfrm>
-          <a:prstGeom prst="rect">
-            <a:avLst/>
-          </a:prstGeom>
-          <a:noFill/>
-          <a:ln/>
-        </p:spPr>
-        <p:txBody>
-          <a:bodyPr wrap="square" rtlCol="0" anchor="ctr"/>
-          <a:lstStyle/>
-          <a:p>
-            <a:pPr marL="0" indent="0" algn="ctr">
-              <a:buNone/>
-            </a:pPr>
-            <a:r>
-              <a:rPr lang="en-US" sz="1500" b="1" dirty="0">
-                <a:solidFill>
-                  <a:srgbClr val="FFFFFF"/>
-                </a:solidFill>
-                <a:latin typeface="Calibri" pitchFamily="34" charset="0"/>
-                <a:ea typeface="Calibri" pitchFamily="34" charset="-122"/>
-                <a:cs typeface="Calibri" pitchFamily="34" charset="-120"/>
-              </a:rPr>
-              <a:t>col-md-4</a:t>
-            </a:r>
-            <a:endParaRPr lang="en-US" sz="1500" dirty="0"/>
-          </a:p>
-        </p:txBody>
-      </p:sp>
-      <p:sp>
-        <p:nvSpPr>
-          <p:cNvPr id="22" name="Shape 19"/>
-          <p:cNvSpPr/>
-          <p:nvPr/>
-        </p:nvSpPr>
-        <p:spPr>
-          <a:xfrm>
-            <a:off x="8101584" y="2743200"/>
-            <a:ext cx="3657600" cy="914400"/>
-          </a:xfrm>
-          <a:prstGeom prst="roundRect">
-            <a:avLst>
-              <a:gd name="adj" fmla="val 6000"/>
-            </a:avLst>
-          </a:prstGeom>
-          <a:solidFill>
-            <a:srgbClr val="7952B3"/>
-          </a:solidFill>
-          <a:ln/>
-        </p:spPr>
-        <p:txBody>
-          <a:bodyPr/>
-          <a:lstStyle/>
-          <a:p>
-            <a:endParaRPr lang="es-ES"/>
-          </a:p>
-        </p:txBody>
-      </p:sp>
-      <p:sp>
-        <p:nvSpPr>
-          <p:cNvPr id="23" name="Text 20"/>
-          <p:cNvSpPr/>
-          <p:nvPr/>
-        </p:nvSpPr>
-        <p:spPr>
-          <a:xfrm>
-            <a:off x="8101584" y="2743200"/>
-            <a:ext cx="3657600" cy="914400"/>
-          </a:xfrm>
-          <a:prstGeom prst="rect">
-            <a:avLst/>
-          </a:prstGeom>
-          <a:noFill/>
-          <a:ln/>
-        </p:spPr>
-        <p:txBody>
-          <a:bodyPr wrap="square" rtlCol="0" anchor="ctr"/>
-          <a:lstStyle/>
-          <a:p>
-            <a:pPr marL="0" indent="0" algn="ctr">
-              <a:buNone/>
-            </a:pPr>
-            <a:r>
-              <a:rPr lang="en-US" sz="1500" b="1" dirty="0">
-                <a:solidFill>
-                  <a:srgbClr val="FFFFFF"/>
-                </a:solidFill>
-                <a:latin typeface="Calibri" pitchFamily="34" charset="0"/>
-                <a:ea typeface="Calibri" pitchFamily="34" charset="-122"/>
-                <a:cs typeface="Calibri" pitchFamily="34" charset="-120"/>
-              </a:rPr>
-              <a:t>col-md-4</a:t>
-            </a:r>
-            <a:endParaRPr lang="en-US" sz="1500" dirty="0"/>
-          </a:p>
-        </p:txBody>
-      </p:sp>
-      <p:sp>
-        <p:nvSpPr>
           <p:cNvPr id="24" name="Text 21"/>
           <p:cNvSpPr/>
           <p:nvPr/>
@@ -3571,7 +3571,7 @@
               <a:buNone/>
             </a:pPr>
             <a:r>
-              <a:rPr lang="en-US" sz="1150" i="1" dirty="0">
+              <a:rPr lang="en-US" sz="1200" i="1" dirty="0">
                 <a:solidFill>
                   <a:srgbClr val="5A5A6E"/>
                 </a:solidFill>
@@ -3581,7 +3581,7 @@
               </a:rPr>
               <a:t>Ejemplo: el formulario de la demo usa col-md-6 y col-md-4 para distribuir campos</a:t>
             </a:r>
-            <a:endParaRPr lang="en-US" sz="1150" dirty="0"/>
+            <a:endParaRPr lang="en-US" sz="1200" dirty="0"/>
           </a:p>
         </p:txBody>
       </p:sp>
@@ -4655,120 +4655,6 @@
       </p:graphicFrame>
       <p:sp>
         <p:nvSpPr>
-          <p:cNvPr id="26" name="Shape 22"/>
-          <p:cNvSpPr/>
-          <p:nvPr/>
-        </p:nvSpPr>
-        <p:spPr>
-          <a:xfrm>
-            <a:off x="6309360" y="4114800"/>
-            <a:ext cx="5303520" cy="1554480"/>
-          </a:xfrm>
-          <a:prstGeom prst="roundRect">
-            <a:avLst>
-              <a:gd name="adj" fmla="val 3529"/>
-            </a:avLst>
-          </a:prstGeom>
-          <a:solidFill>
-            <a:srgbClr val="FFFFFF"/>
-          </a:solidFill>
-          <a:ln/>
-          <a:effectLst>
-            <a:outerShdw blurRad="101600" dist="38100" dir="2700000" algn="bl" rotWithShape="0">
-              <a:srgbClr val="000000">
-                <a:alpha val="12000"/>
-              </a:srgbClr>
-            </a:outerShdw>
-          </a:effectLst>
-        </p:spPr>
-        <p:txBody>
-          <a:bodyPr/>
-          <a:lstStyle/>
-          <a:p>
-            <a:endParaRPr lang="es-ES"/>
-          </a:p>
-        </p:txBody>
-      </p:sp>
-      <p:sp>
-        <p:nvSpPr>
-          <p:cNvPr id="27" name="Text 23"/>
-          <p:cNvSpPr/>
-          <p:nvPr/>
-        </p:nvSpPr>
-        <p:spPr>
-          <a:xfrm>
-            <a:off x="6537960" y="4224528"/>
-            <a:ext cx="4846320" cy="292608"/>
-          </a:xfrm>
-          <a:prstGeom prst="rect">
-            <a:avLst/>
-          </a:prstGeom>
-          <a:noFill/>
-          <a:ln/>
-        </p:spPr>
-        <p:txBody>
-          <a:bodyPr wrap="square" rtlCol="0" anchor="ctr"/>
-          <a:lstStyle/>
-          <a:p>
-            <a:pPr marL="0" indent="0">
-              <a:buNone/>
-            </a:pPr>
-            <a:r>
-              <a:rPr lang="en-US" sz="1250" b="1" dirty="0">
-                <a:solidFill>
-                  <a:srgbClr val="44337A"/>
-                </a:solidFill>
-                <a:latin typeface="Calibri" pitchFamily="34" charset="0"/>
-                <a:ea typeface="Calibri" pitchFamily="34" charset="-122"/>
-                <a:cs typeface="Calibri" pitchFamily="34" charset="-120"/>
-              </a:rPr>
-              <a:t>Tip de defensa en vivo:</a:t>
-            </a:r>
-            <a:endParaRPr lang="en-US" sz="1250" dirty="0"/>
-          </a:p>
-        </p:txBody>
-      </p:sp>
-      <p:sp>
-        <p:nvSpPr>
-          <p:cNvPr id="28" name="Text 24"/>
-          <p:cNvSpPr/>
-          <p:nvPr/>
-        </p:nvSpPr>
-        <p:spPr>
-          <a:xfrm>
-            <a:off x="6537960" y="4526280"/>
-            <a:ext cx="4846320" cy="1005840"/>
-          </a:xfrm>
-          <a:prstGeom prst="rect">
-            <a:avLst/>
-          </a:prstGeom>
-          <a:noFill/>
-          <a:ln/>
-        </p:spPr>
-        <p:txBody>
-          <a:bodyPr wrap="square" rtlCol="0" anchor="ctr"/>
-          <a:lstStyle/>
-          <a:p>
-            <a:pPr marL="0" indent="0">
-              <a:buNone/>
-            </a:pPr>
-            <a:r>
-              <a:rPr lang="en-US" sz="1150" dirty="0">
-                <a:solidFill>
-                  <a:srgbClr val="5A5A6E"/>
-                </a:solidFill>
-                <a:latin typeface="Calibri" pitchFamily="34" charset="0"/>
-                <a:ea typeface="Calibri" pitchFamily="34" charset="-122"/>
-                <a:cs typeface="Calibri" pitchFamily="34" charset="-120"/>
-              </a:rPr>
-              <a:t>Si nos piden cambiar col-md-6 a col-md-4 en vivo, el ancho baja de 50% a 33% de inmediato — sin recargar la página.</a:t>
-            </a:r>
-            <a:endParaRPr lang="en-US" sz="1150" dirty="0"/>
-          </a:p>
-        </p:txBody>
-      </p:sp>
-      <p:sp>
-        <p:nvSpPr>
           <p:cNvPr id="29" name="Text 25"/>
           <p:cNvSpPr/>
           <p:nvPr/>
@@ -4901,7 +4787,7 @@
           <a:bodyPr/>
           <a:lstStyle/>
           <a:p>
-            <a:endParaRPr lang="es-ES"/>
+            <a:endParaRPr lang="es-ES" sz="2000"/>
           </a:p>
         </p:txBody>
       </p:sp>
@@ -4954,7 +4840,7 @@
               <a:buNone/>
             </a:pPr>
             <a:r>
-              <a:rPr lang="en-US" sz="2600" b="1" dirty="0">
+              <a:rPr lang="en-US" sz="2800" b="1" dirty="0">
                 <a:solidFill>
                   <a:srgbClr val="1E1B2E"/>
                 </a:solidFill>
@@ -4964,7 +4850,7 @@
               </a:rPr>
               <a:t>¿Cuándo conviene usarlo... y cuándo no?</a:t>
             </a:r>
-            <a:endParaRPr lang="en-US" sz="2600" dirty="0"/>
+            <a:endParaRPr lang="en-US" sz="2800" dirty="0"/>
           </a:p>
         </p:txBody>
       </p:sp>
@@ -5000,7 +4886,7 @@
           <a:bodyPr/>
           <a:lstStyle/>
           <a:p>
-            <a:endParaRPr lang="es-ES"/>
+            <a:endParaRPr lang="es-ES" sz="2000"/>
           </a:p>
         </p:txBody>
       </p:sp>
@@ -5053,7 +4939,7 @@
               <a:buNone/>
             </a:pPr>
             <a:r>
-              <a:rPr lang="en-US" sz="1600" b="1" dirty="0">
+              <a:rPr lang="en-US" b="1" dirty="0">
                 <a:solidFill>
                   <a:srgbClr val="2E7D32"/>
                 </a:solidFill>
@@ -5063,7 +4949,7 @@
               </a:rPr>
               <a:t>Conviene usarlo cuando...</a:t>
             </a:r>
-            <a:endParaRPr lang="en-US" sz="1600" dirty="0"/>
+            <a:endParaRPr lang="en-US" dirty="0"/>
           </a:p>
         </p:txBody>
       </p:sp>
@@ -5096,7 +4982,7 @@
               <a:buChar char="•"/>
             </a:pPr>
             <a:r>
-              <a:rPr lang="en-US" sz="1300" dirty="0">
+              <a:rPr lang="en-US" sz="1400" dirty="0">
                 <a:solidFill>
                   <a:srgbClr val="1E1B2E"/>
                 </a:solidFill>
@@ -5106,7 +4992,7 @@
               </a:rPr>
               <a:t>Se necesita un prototipo o MVP rápido sin diseñador dedicado</a:t>
             </a:r>
-            <a:endParaRPr lang="en-US" sz="1300" dirty="0"/>
+            <a:endParaRPr lang="en-US" sz="1400" dirty="0"/>
           </a:p>
           <a:p>
             <a:pPr marL="342900" indent="-342900">
@@ -5117,7 +5003,7 @@
               <a:buChar char="•"/>
             </a:pPr>
             <a:r>
-              <a:rPr lang="en-US" sz="1300" dirty="0">
+              <a:rPr lang="en-US" sz="1400" dirty="0">
                 <a:solidFill>
                   <a:srgbClr val="1E1B2E"/>
                 </a:solidFill>
@@ -5127,7 +5013,7 @@
               </a:rPr>
               <a:t>El equipo es pequeño y prioriza velocidad sobre diseño 100% único</a:t>
             </a:r>
-            <a:endParaRPr lang="en-US" sz="1300" dirty="0"/>
+            <a:endParaRPr lang="en-US" sz="1400" dirty="0"/>
           </a:p>
           <a:p>
             <a:pPr marL="342900" indent="-342900">
@@ -5138,7 +5024,7 @@
               <a:buChar char="•"/>
             </a:pPr>
             <a:r>
-              <a:rPr lang="en-US" sz="1300" dirty="0">
+              <a:rPr lang="en-US" sz="1400" dirty="0">
                 <a:solidFill>
                   <a:srgbClr val="1E1B2E"/>
                 </a:solidFill>
@@ -5148,7 +5034,7 @@
               </a:rPr>
               <a:t>Se requiere consistencia visual inmediata (paneles admin, dashboards internos)</a:t>
             </a:r>
-            <a:endParaRPr lang="en-US" sz="1300" dirty="0"/>
+            <a:endParaRPr lang="en-US" sz="1400" dirty="0"/>
           </a:p>
           <a:p>
             <a:pPr marL="342900" indent="-342900">
@@ -5159,7 +5045,7 @@
               <a:buChar char="•"/>
             </a:pPr>
             <a:r>
-              <a:rPr lang="en-US" sz="1300" dirty="0">
+              <a:rPr lang="en-US" sz="1400" dirty="0">
                 <a:solidFill>
                   <a:srgbClr val="1E1B2E"/>
                 </a:solidFill>
@@ -5169,7 +5055,7 @@
               </a:rPr>
               <a:t>El equipo ya conoce Bootstrap y el tiempo de entrega es corto</a:t>
             </a:r>
-            <a:endParaRPr lang="en-US" sz="1300" dirty="0"/>
+            <a:endParaRPr lang="en-US" sz="1400" dirty="0"/>
           </a:p>
         </p:txBody>
       </p:sp>
@@ -5205,7 +5091,7 @@
           <a:bodyPr/>
           <a:lstStyle/>
           <a:p>
-            <a:endParaRPr lang="es-ES"/>
+            <a:endParaRPr lang="es-ES" sz="2000"/>
           </a:p>
         </p:txBody>
       </p:sp>
@@ -5258,7 +5144,7 @@
               <a:buNone/>
             </a:pPr>
             <a:r>
-              <a:rPr lang="en-US" sz="1600" b="1" dirty="0">
+              <a:rPr lang="en-US" b="1" dirty="0">
                 <a:solidFill>
                   <a:srgbClr val="C62828"/>
                 </a:solidFill>
@@ -5268,7 +5154,7 @@
               </a:rPr>
               <a:t>No conviene cuando...</a:t>
             </a:r>
-            <a:endParaRPr lang="en-US" sz="1600" dirty="0"/>
+            <a:endParaRPr lang="en-US" dirty="0"/>
           </a:p>
         </p:txBody>
       </p:sp>
@@ -5301,7 +5187,7 @@
               <a:buChar char="•"/>
             </a:pPr>
             <a:r>
-              <a:rPr lang="en-US" sz="1300" dirty="0">
+              <a:rPr lang="en-US" sz="1400" dirty="0">
                 <a:solidFill>
                   <a:srgbClr val="1E1B2E"/>
                 </a:solidFill>
@@ -5311,7 +5197,7 @@
               </a:rPr>
               <a:t>El proyecto requiere identidad visual 100% a medida (se termina sobrescribiendo casi todo el CSS)</a:t>
             </a:r>
-            <a:endParaRPr lang="en-US" sz="1300" dirty="0"/>
+            <a:endParaRPr lang="en-US" sz="1400" dirty="0"/>
           </a:p>
           <a:p>
             <a:pPr marL="342900" indent="-342900">
@@ -5322,7 +5208,7 @@
               <a:buChar char="•"/>
             </a:pPr>
             <a:r>
-              <a:rPr lang="en-US" sz="1300" dirty="0">
+              <a:rPr lang="en-US" sz="1400" dirty="0">
                 <a:solidFill>
                   <a:srgbClr val="1E1B2E"/>
                 </a:solidFill>
@@ -5332,7 +5218,7 @@
               </a:rPr>
               <a:t>El peso final del bundle importa mucho (apps muy ligeras, sitios de alto rendimiento)</a:t>
             </a:r>
-            <a:endParaRPr lang="en-US" sz="1300" dirty="0"/>
+            <a:endParaRPr lang="en-US" sz="1400" dirty="0"/>
           </a:p>
           <a:p>
             <a:pPr marL="342900" indent="-342900">
@@ -5343,7 +5229,7 @@
               <a:buChar char="•"/>
             </a:pPr>
             <a:r>
-              <a:rPr lang="en-US" sz="1300" dirty="0">
+              <a:rPr lang="en-US" sz="1400" dirty="0">
                 <a:solidFill>
                   <a:srgbClr val="1E1B2E"/>
                 </a:solidFill>
@@ -5353,7 +5239,7 @@
               </a:rPr>
               <a:t>Se quiere evitar JavaScript adicional y solo se necesitan utilidades CSS puras</a:t>
             </a:r>
-            <a:endParaRPr lang="en-US" sz="1300" dirty="0"/>
+            <a:endParaRPr lang="en-US" sz="1400" dirty="0"/>
           </a:p>
         </p:txBody>
       </p:sp>
@@ -5489,11 +5375,11 @@
           <a:bodyPr wrap="square" rtlCol="0" anchor="ctr"/>
           <a:lstStyle/>
           <a:p>
-            <a:pPr marL="0" indent="0">
+            <a:pPr marL="0" indent="0" algn="ctr">
               <a:buNone/>
             </a:pPr>
             <a:r>
-              <a:rPr lang="en-US" sz="2800" b="1" dirty="0">
+              <a:rPr lang="en-US" sz="3200" b="1" dirty="0">
                 <a:solidFill>
                   <a:srgbClr val="FFFFFF"/>
                 </a:solidFill>
@@ -5503,7 +5389,7 @@
               </a:rPr>
               <a:t>Bootstrap vs. Tailwind CSS</a:t>
             </a:r>
-            <a:endParaRPr lang="en-US" sz="2800" dirty="0"/>
+            <a:endParaRPr lang="en-US" sz="3200" dirty="0"/>
           </a:p>
         </p:txBody>
       </p:sp>
@@ -5530,7 +5416,7 @@
           <a:bodyPr/>
           <a:lstStyle/>
           <a:p>
-            <a:endParaRPr lang="es-ES"/>
+            <a:endParaRPr lang="es-ES" sz="2400"/>
           </a:p>
         </p:txBody>
       </p:sp>
@@ -5559,7 +5445,7 @@
               <a:buNone/>
             </a:pPr>
             <a:r>
-              <a:rPr lang="en-US" sz="1600" b="1" dirty="0">
+              <a:rPr lang="en-US" sz="2000" b="1" dirty="0">
                 <a:solidFill>
                   <a:srgbClr val="FFFFFF"/>
                 </a:solidFill>
@@ -5569,7 +5455,7 @@
               </a:rPr>
               <a:t>VS</a:t>
             </a:r>
-            <a:endParaRPr lang="en-US" sz="1600" dirty="0"/>
+            <a:endParaRPr lang="en-US" sz="2000" dirty="0"/>
           </a:p>
         </p:txBody>
       </p:sp>
@@ -5582,7 +5468,7 @@
           <p:nvPr>
             <p:extLst>
               <p:ext uri="{D42A27DB-BD31-4B8C-83A1-F6EECF244321}">
-                <p14:modId xmlns:p14="http://schemas.microsoft.com/office/powerpoint/2010/main" val="1579011935"/>
+                <p14:modId xmlns:p14="http://schemas.microsoft.com/office/powerpoint/2010/main" val="2666336708"/>
               </p:ext>
             </p:extLst>
           </p:nvPr>
@@ -5839,7 +5725,7 @@
                         <a:buNone/>
                       </a:pPr>
                       <a:r>
-                        <a:rPr lang="en-US" sz="1250" b="1" dirty="0">
+                        <a:rPr lang="en-US" sz="1400" b="1" dirty="0">
                           <a:solidFill>
                             <a:srgbClr val="EFE9F7"/>
                           </a:solidFill>
@@ -5849,7 +5735,7 @@
                         </a:rPr>
                         <a:t>Enfoque</a:t>
                       </a:r>
-                      <a:endParaRPr lang="en-US" sz="1250" dirty="0">
+                      <a:endParaRPr lang="en-US" sz="1400" dirty="0">
                         <a:latin typeface="Calibri" charset="0"/>
                         <a:ea typeface="Calibri" charset="0"/>
                         <a:cs typeface="Calibri" charset="0"/>
@@ -5907,7 +5793,7 @@
                         <a:buNone/>
                       </a:pPr>
                       <a:r>
-                        <a:rPr lang="en-US" sz="1250" dirty="0">
+                        <a:rPr lang="en-US" sz="1400" dirty="0">
                           <a:solidFill>
                             <a:srgbClr val="FFFFFF"/>
                           </a:solidFill>
@@ -5917,7 +5803,7 @@
                         </a:rPr>
                         <a:t>Componentes ya armados (btn, card, navbar)</a:t>
                       </a:r>
-                      <a:endParaRPr lang="en-US" sz="1250" dirty="0">
+                      <a:endParaRPr lang="en-US" sz="1400" dirty="0">
                         <a:latin typeface="Calibri" charset="0"/>
                         <a:ea typeface="Calibri" charset="0"/>
                         <a:cs typeface="Calibri" charset="0"/>
@@ -5975,7 +5861,7 @@
                         <a:buNone/>
                       </a:pPr>
                       <a:r>
-                        <a:rPr lang="en-US" sz="1250" dirty="0">
+                        <a:rPr lang="en-US" sz="1400" dirty="0">
                           <a:solidFill>
                             <a:srgbClr val="FFFFFF"/>
                           </a:solidFill>
@@ -5985,7 +5871,7 @@
                         </a:rPr>
                         <a:t>Utilidades atómicas (flex, p-4, text-center)</a:t>
                       </a:r>
-                      <a:endParaRPr lang="en-US" sz="1250" dirty="0">
+                      <a:endParaRPr lang="en-US" sz="1400" dirty="0">
                         <a:latin typeface="Calibri" charset="0"/>
                         <a:ea typeface="Calibri" charset="0"/>
                         <a:cs typeface="Calibri" charset="0"/>
@@ -6050,7 +5936,7 @@
                         <a:buNone/>
                       </a:pPr>
                       <a:r>
-                        <a:rPr lang="en-US" sz="1250" b="1" dirty="0">
+                        <a:rPr lang="en-US" sz="1400" b="1" dirty="0">
                           <a:solidFill>
                             <a:srgbClr val="EFE9F7"/>
                           </a:solidFill>
@@ -6060,7 +5946,7 @@
                         </a:rPr>
                         <a:t>Curva de aprendizaje</a:t>
                       </a:r>
-                      <a:endParaRPr lang="en-US" sz="1250" dirty="0">
+                      <a:endParaRPr lang="en-US" sz="1400" dirty="0">
                         <a:latin typeface="Calibri" charset="0"/>
                         <a:ea typeface="Calibri" charset="0"/>
                         <a:cs typeface="Calibri" charset="0"/>
@@ -6118,7 +6004,7 @@
                         <a:buNone/>
                       </a:pPr>
                       <a:r>
-                        <a:rPr lang="en-US" sz="1250" dirty="0">
+                        <a:rPr lang="en-US" sz="1400" dirty="0">
                           <a:solidFill>
                             <a:srgbClr val="FFFFFF"/>
                           </a:solidFill>
@@ -6128,7 +6014,7 @@
                         </a:rPr>
                         <a:t>Baja al inicio</a:t>
                       </a:r>
-                      <a:endParaRPr lang="en-US" sz="1250" dirty="0">
+                      <a:endParaRPr lang="en-US" sz="1400" dirty="0">
                         <a:latin typeface="Calibri" charset="0"/>
                         <a:ea typeface="Calibri" charset="0"/>
                         <a:cs typeface="Calibri" charset="0"/>
@@ -6186,7 +6072,7 @@
                         <a:buNone/>
                       </a:pPr>
                       <a:r>
-                        <a:rPr lang="en-US" sz="1250" dirty="0">
+                        <a:rPr lang="en-US" sz="1400" dirty="0">
                           <a:solidFill>
                             <a:srgbClr val="FFFFFF"/>
                           </a:solidFill>
@@ -6196,7 +6082,7 @@
                         </a:rPr>
                         <a:t>Más alta al inicio, más control después</a:t>
                       </a:r>
-                      <a:endParaRPr lang="en-US" sz="1250" dirty="0">
+                      <a:endParaRPr lang="en-US" sz="1400" dirty="0">
                         <a:latin typeface="Calibri" charset="0"/>
                         <a:ea typeface="Calibri" charset="0"/>
                         <a:cs typeface="Calibri" charset="0"/>
@@ -6261,7 +6147,7 @@
                         <a:buNone/>
                       </a:pPr>
                       <a:r>
-                        <a:rPr lang="en-US" sz="1250" b="1" dirty="0">
+                        <a:rPr lang="en-US" sz="1400" b="1" dirty="0">
                           <a:solidFill>
                             <a:srgbClr val="EFE9F7"/>
                           </a:solidFill>
@@ -6271,7 +6157,7 @@
                         </a:rPr>
                         <a:t>Personalización</a:t>
                       </a:r>
-                      <a:endParaRPr lang="en-US" sz="1250" dirty="0">
+                      <a:endParaRPr lang="en-US" sz="1400" dirty="0">
                         <a:latin typeface="Calibri" charset="0"/>
                         <a:ea typeface="Calibri" charset="0"/>
                         <a:cs typeface="Calibri" charset="0"/>
@@ -6329,7 +6215,7 @@
                         <a:buNone/>
                       </a:pPr>
                       <a:r>
-                        <a:rPr lang="en-US" sz="1250" dirty="0">
+                        <a:rPr lang="en-US" sz="1400" dirty="0">
                           <a:solidFill>
                             <a:srgbClr val="FFFFFF"/>
                           </a:solidFill>
@@ -6339,7 +6225,7 @@
                         </a:rPr>
                         <a:t>Variables Sass + recompilar</a:t>
                       </a:r>
-                      <a:endParaRPr lang="en-US" sz="1250" dirty="0">
+                      <a:endParaRPr lang="en-US" sz="1400" dirty="0">
                         <a:latin typeface="Calibri" charset="0"/>
                         <a:ea typeface="Calibri" charset="0"/>
                         <a:cs typeface="Calibri" charset="0"/>
@@ -6397,7 +6283,7 @@
                         <a:buNone/>
                       </a:pPr>
                       <a:r>
-                        <a:rPr lang="en-US" sz="1250" dirty="0">
+                        <a:rPr lang="en-US" sz="1400" dirty="0">
                           <a:solidFill>
                             <a:srgbClr val="FFFFFF"/>
                           </a:solidFill>
@@ -6407,7 +6293,7 @@
                         </a:rPr>
                         <a:t>tailwind.config.js, muy flexible</a:t>
                       </a:r>
-                      <a:endParaRPr lang="en-US" sz="1250" dirty="0">
+                      <a:endParaRPr lang="en-US" sz="1400" dirty="0">
                         <a:latin typeface="Calibri" charset="0"/>
                         <a:ea typeface="Calibri" charset="0"/>
                         <a:cs typeface="Calibri" charset="0"/>
@@ -6472,7 +6358,7 @@
                         <a:buNone/>
                       </a:pPr>
                       <a:r>
-                        <a:rPr lang="en-US" sz="1250" b="1" dirty="0">
+                        <a:rPr lang="en-US" sz="1400" b="1" dirty="0">
                           <a:solidFill>
                             <a:srgbClr val="EFE9F7"/>
                           </a:solidFill>
@@ -6482,7 +6368,7 @@
                         </a:rPr>
                         <a:t>JS incluido</a:t>
                       </a:r>
-                      <a:endParaRPr lang="en-US" sz="1250" dirty="0">
+                      <a:endParaRPr lang="en-US" sz="1400" dirty="0">
                         <a:latin typeface="Calibri" charset="0"/>
                         <a:ea typeface="Calibri" charset="0"/>
                         <a:cs typeface="Calibri" charset="0"/>
@@ -6540,7 +6426,7 @@
                         <a:buNone/>
                       </a:pPr>
                       <a:r>
-                        <a:rPr lang="en-US" sz="1250" dirty="0">
+                        <a:rPr lang="en-US" sz="1400" dirty="0">
                           <a:solidFill>
                             <a:srgbClr val="FFFFFF"/>
                           </a:solidFill>
@@ -6550,7 +6436,7 @@
                         </a:rPr>
                         <a:t>Sí (modales, dropdowns, carousels)</a:t>
                       </a:r>
-                      <a:endParaRPr lang="en-US" sz="1250" dirty="0">
+                      <a:endParaRPr lang="en-US" sz="1400" dirty="0">
                         <a:latin typeface="Calibri" charset="0"/>
                         <a:ea typeface="Calibri" charset="0"/>
                         <a:cs typeface="Calibri" charset="0"/>
@@ -6608,7 +6494,7 @@
                         <a:buNone/>
                       </a:pPr>
                       <a:r>
-                        <a:rPr lang="en-US" sz="1250" dirty="0">
+                        <a:rPr lang="en-US" sz="1400" dirty="0">
                           <a:solidFill>
                             <a:srgbClr val="FFFFFF"/>
                           </a:solidFill>
@@ -6618,7 +6504,7 @@
                         </a:rPr>
                         <a:t>No, solo CSS</a:t>
                       </a:r>
-                      <a:endParaRPr lang="en-US" sz="1250" dirty="0">
+                      <a:endParaRPr lang="en-US" sz="1400" dirty="0">
                         <a:latin typeface="Calibri" charset="0"/>
                         <a:ea typeface="Calibri" charset="0"/>
                         <a:cs typeface="Calibri" charset="0"/>
@@ -6683,7 +6569,7 @@
                         <a:buNone/>
                       </a:pPr>
                       <a:r>
-                        <a:rPr lang="en-US" sz="1250" b="1" dirty="0">
+                        <a:rPr lang="en-US" sz="1400" b="1" dirty="0">
                           <a:solidFill>
                             <a:srgbClr val="EFE9F7"/>
                           </a:solidFill>
@@ -6693,7 +6579,7 @@
                         </a:rPr>
                         <a:t>Tamaño final</a:t>
                       </a:r>
-                      <a:endParaRPr lang="en-US" sz="1250" dirty="0">
+                      <a:endParaRPr lang="en-US" sz="1400" dirty="0">
                         <a:latin typeface="Calibri" charset="0"/>
                         <a:ea typeface="Calibri" charset="0"/>
                         <a:cs typeface="Calibri" charset="0"/>
@@ -6751,7 +6637,7 @@
                         <a:buNone/>
                       </a:pPr>
                       <a:r>
-                        <a:rPr lang="en-US" sz="1250" dirty="0">
+                        <a:rPr lang="en-US" sz="1400" dirty="0">
                           <a:solidFill>
                             <a:srgbClr val="FFFFFF"/>
                           </a:solidFill>
@@ -6761,7 +6647,7 @@
                         </a:rPr>
                         <a:t>Más pesado si no se purga CSS</a:t>
                       </a:r>
-                      <a:endParaRPr lang="en-US" sz="1250" dirty="0">
+                      <a:endParaRPr lang="en-US" sz="1400" dirty="0">
                         <a:latin typeface="Calibri" charset="0"/>
                         <a:ea typeface="Calibri" charset="0"/>
                         <a:cs typeface="Calibri" charset="0"/>
@@ -6819,7 +6705,7 @@
                         <a:buNone/>
                       </a:pPr>
                       <a:r>
-                        <a:rPr lang="en-US" sz="1250" dirty="0">
+                        <a:rPr lang="en-US" sz="1400" dirty="0">
                           <a:solidFill>
                             <a:srgbClr val="FFFFFF"/>
                           </a:solidFill>
@@ -6829,7 +6715,7 @@
                         </a:rPr>
                         <a:t>Liviano (purga automática)</a:t>
                       </a:r>
-                      <a:endParaRPr lang="en-US" sz="1250" dirty="0">
+                      <a:endParaRPr lang="en-US" sz="1400" dirty="0">
                         <a:latin typeface="Calibri" charset="0"/>
                         <a:ea typeface="Calibri" charset="0"/>
                         <a:cs typeface="Calibri" charset="0"/>
@@ -6913,7 +6799,7 @@
               <a:buNone/>
             </a:pPr>
             <a:r>
-              <a:rPr lang="en-US" sz="1250" i="1" dirty="0">
+              <a:rPr lang="en-US" sz="1400" i="1" dirty="0">
                 <a:solidFill>
                   <a:srgbClr val="EFE9F7"/>
                 </a:solidFill>
@@ -6923,7 +6809,7 @@
               </a:rPr>
               <a:t>Ambos resuelven "diseño responsive consistente": Bootstrap entrega componentes listos, Tailwind entrega control granular sin opinión visual.</a:t>
             </a:r>
-            <a:endParaRPr lang="en-US" sz="1250" dirty="0"/>
+            <a:endParaRPr lang="en-US" sz="1400" dirty="0"/>
           </a:p>
         </p:txBody>
       </p:sp>
@@ -7007,10 +6893,10 @@
       </p:sp>
       <p:pic>
         <p:nvPicPr>
-          <p:cNvPr id="13" name="Imagen 12" descr="Bootstrap Logo PNG Vector (EPS) Free Download">
+          <p:cNvPr id="6" name="Imagen 5">
             <a:extLst>
               <a:ext uri="{FF2B5EF4-FFF2-40B4-BE49-F238E27FC236}">
-                <a16:creationId xmlns:a16="http://schemas.microsoft.com/office/drawing/2014/main" id="{329B818E-0BE4-2142-716A-15AC219BDB9F}"/>
+                <a16:creationId xmlns:a16="http://schemas.microsoft.com/office/drawing/2014/main" id="{19196CE1-6BF8-9BED-B3D6-77EDA52D6D55}"/>
               </a:ext>
             </a:extLst>
           </p:cNvPr>
@@ -7027,8 +6913,8 @@
         </p:blipFill>
         <p:spPr>
           <a:xfrm>
-            <a:off x="1602740" y="919480"/>
-            <a:ext cx="1275080" cy="1275080"/>
+            <a:off x="808672" y="563139"/>
+            <a:ext cx="2589848" cy="1726565"/>
           </a:xfrm>
           <a:prstGeom prst="rect">
             <a:avLst/>
@@ -7037,10 +6923,10 @@
       </p:pic>
       <p:pic>
         <p:nvPicPr>
-          <p:cNvPr id="14" name="Imagen 13" descr="Tailwind CSS Logo Vector - (.SVG + .PNG) - GetLogoVector.Com">
+          <p:cNvPr id="19" name="Imagen 18" descr="Archivo:Tailwind CSS Logo.svg - Wikipedia, la enciclopedia libre">
             <a:extLst>
               <a:ext uri="{FF2B5EF4-FFF2-40B4-BE49-F238E27FC236}">
-                <a16:creationId xmlns:a16="http://schemas.microsoft.com/office/drawing/2014/main" id="{75B5FB54-7340-4088-92BD-CBDF1836D284}"/>
+                <a16:creationId xmlns:a16="http://schemas.microsoft.com/office/drawing/2014/main" id="{3C9EAC29-3138-4C2B-1206-FDA4EC2ED019}"/>
               </a:ext>
             </a:extLst>
           </p:cNvPr>
@@ -7057,8 +6943,8 @@
         </p:blipFill>
         <p:spPr>
           <a:xfrm>
-            <a:off x="7894320" y="749725"/>
-            <a:ext cx="2439352" cy="1353395"/>
+            <a:off x="8126519" y="930819"/>
+            <a:ext cx="1805833" cy="1103721"/>
           </a:xfrm>
           <a:prstGeom prst="rect">
             <a:avLst/>
@@ -7251,7 +7137,7 @@
           <a:bodyPr/>
           <a:lstStyle/>
           <a:p>
-            <a:endParaRPr lang="es-ES"/>
+            <a:endParaRPr lang="es-ES" sz="2000"/>
           </a:p>
         </p:txBody>
       </p:sp>
@@ -7280,7 +7166,7 @@
               <a:buNone/>
             </a:pPr>
             <a:r>
-              <a:rPr lang="en-US" sz="3200" b="1" dirty="0">
+              <a:rPr lang="en-US" sz="3600" b="1" dirty="0">
                 <a:solidFill>
                   <a:srgbClr val="44337A"/>
                 </a:solidFill>
@@ -7290,7 +7176,7 @@
               </a:rPr>
               <a:t>5.3.8</a:t>
             </a:r>
-            <a:endParaRPr lang="en-US" sz="3200" dirty="0"/>
+            <a:endParaRPr lang="en-US" sz="3600" dirty="0"/>
           </a:p>
         </p:txBody>
       </p:sp>
@@ -7319,7 +7205,7 @@
               <a:buNone/>
             </a:pPr>
             <a:r>
-              <a:rPr lang="en-US" sz="1150" dirty="0">
+              <a:rPr lang="en-US" sz="1200" dirty="0">
                 <a:solidFill>
                   <a:srgbClr val="5A5A6E"/>
                 </a:solidFill>
@@ -7329,14 +7215,14 @@
               </a:rPr>
               <a:t>Versión estable</a:t>
             </a:r>
-            <a:endParaRPr lang="en-US" sz="1150" dirty="0"/>
+            <a:endParaRPr lang="en-US" sz="1200" dirty="0"/>
           </a:p>
           <a:p>
             <a:pPr marL="0" indent="0" algn="ctr">
               <a:buNone/>
             </a:pPr>
             <a:r>
-              <a:rPr lang="en-US" sz="1150" dirty="0">
+              <a:rPr lang="en-US" sz="1200" dirty="0">
                 <a:solidFill>
                   <a:srgbClr val="5A5A6E"/>
                 </a:solidFill>
@@ -7346,7 +7232,7 @@
               </a:rPr>
               <a:t>actual</a:t>
             </a:r>
-            <a:endParaRPr lang="en-US" sz="1150" dirty="0"/>
+            <a:endParaRPr lang="en-US" sz="1200" dirty="0"/>
           </a:p>
         </p:txBody>
       </p:sp>
@@ -7382,7 +7268,7 @@
           <a:bodyPr/>
           <a:lstStyle/>
           <a:p>
-            <a:endParaRPr lang="es-ES"/>
+            <a:endParaRPr lang="es-ES" sz="2000"/>
           </a:p>
         </p:txBody>
       </p:sp>
@@ -7411,7 +7297,7 @@
               <a:buNone/>
             </a:pPr>
             <a:r>
-              <a:rPr lang="en-US" sz="3200" b="1" dirty="0">
+              <a:rPr lang="en-US" sz="3600" b="1" dirty="0">
                 <a:solidFill>
                   <a:srgbClr val="44337A"/>
                 </a:solidFill>
@@ -7421,7 +7307,7 @@
               </a:rPr>
               <a:t>2011</a:t>
             </a:r>
-            <a:endParaRPr lang="en-US" sz="3200" dirty="0"/>
+            <a:endParaRPr lang="en-US" sz="3600" dirty="0"/>
           </a:p>
         </p:txBody>
       </p:sp>
@@ -7450,7 +7336,7 @@
               <a:buNone/>
             </a:pPr>
             <a:r>
-              <a:rPr lang="en-US" sz="1150" dirty="0">
+              <a:rPr lang="en-US" sz="1200" dirty="0">
                 <a:solidFill>
                   <a:srgbClr val="5A5A6E"/>
                 </a:solidFill>
@@ -7460,14 +7346,14 @@
               </a:rPr>
               <a:t>Año de lanzamiento</a:t>
             </a:r>
-            <a:endParaRPr lang="en-US" sz="1150" dirty="0"/>
+            <a:endParaRPr lang="en-US" sz="1200" dirty="0"/>
           </a:p>
           <a:p>
             <a:pPr marL="0" indent="0" algn="ctr">
               <a:buNone/>
             </a:pPr>
             <a:r>
-              <a:rPr lang="en-US" sz="1150" dirty="0">
+              <a:rPr lang="en-US" sz="1200" dirty="0">
                 <a:solidFill>
                   <a:srgbClr val="5A5A6E"/>
                 </a:solidFill>
@@ -7477,7 +7363,7 @@
               </a:rPr>
               <a:t>(Twitter)</a:t>
             </a:r>
-            <a:endParaRPr lang="en-US" sz="1150" dirty="0"/>
+            <a:endParaRPr lang="en-US" sz="1200" dirty="0"/>
           </a:p>
         </p:txBody>
       </p:sp>
@@ -7513,7 +7399,7 @@
           <a:bodyPr/>
           <a:lstStyle/>
           <a:p>
-            <a:endParaRPr lang="es-ES"/>
+            <a:endParaRPr lang="es-ES" sz="2000"/>
           </a:p>
         </p:txBody>
       </p:sp>
@@ -7542,7 +7428,7 @@
               <a:buNone/>
             </a:pPr>
             <a:r>
-              <a:rPr lang="en-US" sz="3200" b="1" dirty="0">
+              <a:rPr lang="en-US" sz="3600" b="1" dirty="0">
                 <a:solidFill>
                   <a:srgbClr val="44337A"/>
                 </a:solidFill>
@@ -7552,7 +7438,7 @@
               </a:rPr>
               <a:t>MIT</a:t>
             </a:r>
-            <a:endParaRPr lang="en-US" sz="3200" dirty="0"/>
+            <a:endParaRPr lang="en-US" sz="3600" dirty="0"/>
           </a:p>
         </p:txBody>
       </p:sp>
@@ -7581,7 +7467,7 @@
               <a:buNone/>
             </a:pPr>
             <a:r>
-              <a:rPr lang="en-US" sz="1150" dirty="0">
+              <a:rPr lang="en-US" sz="1200" dirty="0">
                 <a:solidFill>
                   <a:srgbClr val="5A5A6E"/>
                 </a:solidFill>
@@ -7591,14 +7477,14 @@
               </a:rPr>
               <a:t>Licencia de</a:t>
             </a:r>
-            <a:endParaRPr lang="en-US" sz="1150" dirty="0"/>
+            <a:endParaRPr lang="en-US" sz="1200" dirty="0"/>
           </a:p>
           <a:p>
             <a:pPr marL="0" indent="0" algn="ctr">
               <a:buNone/>
             </a:pPr>
             <a:r>
-              <a:rPr lang="en-US" sz="1150" dirty="0">
+              <a:rPr lang="en-US" sz="1200" dirty="0">
                 <a:solidFill>
                   <a:srgbClr val="5A5A6E"/>
                 </a:solidFill>
@@ -7608,7 +7494,7 @@
               </a:rPr>
               <a:t>código abierto</a:t>
             </a:r>
-            <a:endParaRPr lang="en-US" sz="1150" dirty="0"/>
+            <a:endParaRPr lang="en-US" sz="1200" dirty="0"/>
           </a:p>
         </p:txBody>
       </p:sp>
@@ -7620,7 +7506,7 @@
         </p:nvSpPr>
         <p:spPr>
           <a:xfrm>
-            <a:off x="548640" y="3337560"/>
+            <a:off x="548640" y="4492752"/>
             <a:ext cx="11064240" cy="1371600"/>
           </a:xfrm>
           <a:prstGeom prst="roundRect">
@@ -7644,7 +7530,7 @@
           <a:bodyPr/>
           <a:lstStyle/>
           <a:p>
-            <a:endParaRPr lang="es-ES"/>
+            <a:endParaRPr lang="es-ES" sz="2000"/>
           </a:p>
         </p:txBody>
       </p:sp>
@@ -7656,7 +7542,7 @@
         </p:nvSpPr>
         <p:spPr>
           <a:xfrm>
-            <a:off x="868680" y="3502152"/>
+            <a:off x="868680" y="4663440"/>
             <a:ext cx="10424160" cy="320040"/>
           </a:xfrm>
           <a:prstGeom prst="rect">
@@ -7673,7 +7559,7 @@
               <a:buNone/>
             </a:pPr>
             <a:r>
-              <a:rPr lang="en-US" sz="1200" b="1" dirty="0">
+              <a:rPr lang="en-US" sz="1400" b="1" dirty="0">
                 <a:solidFill>
                   <a:srgbClr val="EFE9F7"/>
                 </a:solidFill>
@@ -7683,7 +7569,7 @@
               </a:rPr>
               <a:t>Fuente: documentación oficial getbootstrap.com (Bootstrap, front-end framework)</a:t>
             </a:r>
-            <a:endParaRPr lang="en-US" sz="1200" dirty="0"/>
+            <a:endParaRPr lang="en-US" sz="1400" dirty="0"/>
           </a:p>
         </p:txBody>
       </p:sp>
@@ -7695,7 +7581,7 @@
         </p:nvSpPr>
         <p:spPr>
           <a:xfrm>
-            <a:off x="868680" y="3840480"/>
+            <a:off x="868680" y="5074920"/>
             <a:ext cx="10424160" cy="777240"/>
           </a:xfrm>
           <a:prstGeom prst="rect">
@@ -7712,7 +7598,7 @@
               <a:buNone/>
             </a:pPr>
             <a:r>
-              <a:rPr lang="en-US" sz="1250" dirty="0">
+              <a:rPr lang="en-US" sz="1400" dirty="0">
                 <a:solidFill>
                   <a:srgbClr val="FFFFFF"/>
                 </a:solidFill>
@@ -7722,85 +7608,7 @@
               </a:rPr>
               <a:t>La versión 5.3 reescribió el núcleo de Bootstrap para dar soporte nativo a modo oscuro y variables CSS, sin dependencia de jQuery.</a:t>
             </a:r>
-            <a:endParaRPr lang="en-US" sz="1250" dirty="0"/>
-          </a:p>
-        </p:txBody>
-      </p:sp>
-      <p:sp>
-        <p:nvSpPr>
-          <p:cNvPr id="18" name="Text 15"/>
-          <p:cNvSpPr/>
-          <p:nvPr/>
-        </p:nvSpPr>
-        <p:spPr>
-          <a:xfrm>
-            <a:off x="548640" y="5029200"/>
-            <a:ext cx="10058400" cy="548640"/>
-          </a:xfrm>
-          <a:prstGeom prst="rect">
-            <a:avLst/>
-          </a:prstGeom>
-          <a:noFill/>
-          <a:ln/>
-        </p:spPr>
-        <p:txBody>
-          <a:bodyPr wrap="square" rtlCol="0" anchor="ctr"/>
-          <a:lstStyle/>
-          <a:p>
-            <a:pPr marL="0" indent="0">
-              <a:buNone/>
-            </a:pPr>
-            <a:r>
-              <a:rPr lang="en-US" sz="2600" b="1" dirty="0">
-                <a:solidFill>
-                  <a:srgbClr val="FFFFFF"/>
-                </a:solidFill>
-                <a:latin typeface="Calibri" pitchFamily="34" charset="0"/>
-                <a:ea typeface="Calibri" pitchFamily="34" charset="-122"/>
-                <a:cs typeface="Calibri" pitchFamily="34" charset="-120"/>
-              </a:rPr>
-              <a:t>Ahora, la demo en vivo</a:t>
-            </a:r>
-            <a:endParaRPr lang="en-US" sz="2600" dirty="0"/>
-          </a:p>
-        </p:txBody>
-      </p:sp>
-      <p:sp>
-        <p:nvSpPr>
-          <p:cNvPr id="19" name="Text 16"/>
-          <p:cNvSpPr/>
-          <p:nvPr/>
-        </p:nvSpPr>
-        <p:spPr>
-          <a:xfrm>
-            <a:off x="548640" y="5623560"/>
-            <a:ext cx="9601200" cy="411480"/>
-          </a:xfrm>
-          <a:prstGeom prst="rect">
-            <a:avLst/>
-          </a:prstGeom>
-          <a:noFill/>
-          <a:ln/>
-        </p:spPr>
-        <p:txBody>
-          <a:bodyPr wrap="square" rtlCol="0" anchor="ctr"/>
-          <a:lstStyle/>
-          <a:p>
-            <a:pPr marL="0" indent="0">
-              <a:buNone/>
-            </a:pPr>
-            <a:r>
-              <a:rPr lang="en-US" sz="1300" dirty="0">
-                <a:solidFill>
-                  <a:srgbClr val="EFE9F7"/>
-                </a:solidFill>
-                <a:latin typeface="Calibri" pitchFamily="34" charset="0"/>
-                <a:ea typeface="Calibri" pitchFamily="34" charset="-122"/>
-                <a:cs typeface="Calibri" pitchFamily="34" charset="-120"/>
-              </a:rPr>
-              <a:t>Panel de inscripción con grid de 12 columnas, carousel y accordion construidos con Bootstrap 5.3 vía Sass</a:t>
-            </a:r>
-            <a:endParaRPr lang="en-US" sz="1300" dirty="0"/>
+            <a:endParaRPr lang="en-US" sz="1400" dirty="0"/>
           </a:p>
         </p:txBody>
       </p:sp>

</xml_diff>